<commit_message>
integrate runtime-only private 108 lens tool
</commit_message>
<xml_diff>
--- a/submission/XiangLens_Track2_Deck.pptx
+++ b/submission/XiangLens_Track2_Deck.pptx
@@ -2,21 +2,21 @@
 <file path=ppt/presentation.xml><?xml version="1.0" encoding="utf-8"?>
 <p:presentation xmlns:p="http://schemas.openxmlformats.org/presentationml/2006/main">
   <p:sldMasterIdLst>
-    <p:sldMasterId xmlns:r="http://schemas.openxmlformats.org/officeDocument/2006/relationships" id="2147483648" r:id="Re960455625ea4afa"/>
+    <p:sldMasterId xmlns:r="http://schemas.openxmlformats.org/officeDocument/2006/relationships" id="2147483648" r:id="R288838dda4614074"/>
   </p:sldMasterIdLst>
   <p:notesMasterIdLst>
-    <p:notesMasterId xmlns:r="http://schemas.openxmlformats.org/officeDocument/2006/relationships" r:id="R76b9fd8818fa40ae"/>
+    <p:notesMasterId xmlns:r="http://schemas.openxmlformats.org/officeDocument/2006/relationships" r:id="R3cb5a82abb03466c"/>
   </p:notesMasterIdLst>
   <p:sldIdLst>
-    <p:sldId xmlns:r="http://schemas.openxmlformats.org/officeDocument/2006/relationships" id="256" r:id="R8d1e99bfcdb34d34"/>
-    <p:sldId xmlns:r="http://schemas.openxmlformats.org/officeDocument/2006/relationships" id="257" r:id="R1b007f0788c1421e"/>
-    <p:sldId xmlns:r="http://schemas.openxmlformats.org/officeDocument/2006/relationships" id="258" r:id="Rbfaf8edce76f4a17"/>
-    <p:sldId xmlns:r="http://schemas.openxmlformats.org/officeDocument/2006/relationships" id="259" r:id="R97c887109006452f"/>
-    <p:sldId xmlns:r="http://schemas.openxmlformats.org/officeDocument/2006/relationships" id="260" r:id="Rde284b29f9324d84"/>
-    <p:sldId xmlns:r="http://schemas.openxmlformats.org/officeDocument/2006/relationships" id="261" r:id="R3a75f041ac2f49b3"/>
-    <p:sldId xmlns:r="http://schemas.openxmlformats.org/officeDocument/2006/relationships" id="262" r:id="Rc0321bbbfefd4030"/>
-    <p:sldId xmlns:r="http://schemas.openxmlformats.org/officeDocument/2006/relationships" id="263" r:id="Ra2b025d2f6a64344"/>
-    <p:sldId xmlns:r="http://schemas.openxmlformats.org/officeDocument/2006/relationships" id="264" r:id="Rade6aebafc5246cf"/>
+    <p:sldId xmlns:r="http://schemas.openxmlformats.org/officeDocument/2006/relationships" id="256" r:id="Ra7e1d648548d4057"/>
+    <p:sldId xmlns:r="http://schemas.openxmlformats.org/officeDocument/2006/relationships" id="257" r:id="Rd8bbed31e0fe455c"/>
+    <p:sldId xmlns:r="http://schemas.openxmlformats.org/officeDocument/2006/relationships" id="258" r:id="R9a2e4a5c18df48d9"/>
+    <p:sldId xmlns:r="http://schemas.openxmlformats.org/officeDocument/2006/relationships" id="259" r:id="R8a1790405ce84e5a"/>
+    <p:sldId xmlns:r="http://schemas.openxmlformats.org/officeDocument/2006/relationships" id="260" r:id="Ra6a540cc30a94066"/>
+    <p:sldId xmlns:r="http://schemas.openxmlformats.org/officeDocument/2006/relationships" id="261" r:id="Ree6a982afcde4af1"/>
+    <p:sldId xmlns:r="http://schemas.openxmlformats.org/officeDocument/2006/relationships" id="262" r:id="Rbc6bc67d78de4957"/>
+    <p:sldId xmlns:r="http://schemas.openxmlformats.org/officeDocument/2006/relationships" id="263" r:id="R742ef352aefc488c"/>
+    <p:sldId xmlns:r="http://schemas.openxmlformats.org/officeDocument/2006/relationships" id="264" r:id="Ra03ec0cc41dd49a1"/>
   </p:sldIdLst>
   <p:sldSz cx="12192000" cy="6858000"/>
   <p:notesSz cx="6858000" cy="9144000"/>
@@ -620,12 +620,12 @@
           </a:p>
           <a:p xmlns:a="http://schemas.openxmlformats.org/drawingml/2006/main">
             <a:r>
-              <a:t>- Actual XiangLens Nuxt interface captured from apps/web in local static-preview mode; no model output was fabricated.</a:t>
-            </a:r>
-          </a:p>
-          <a:p xmlns:a="http://schemas.openxmlformats.org/drawingml/2006/main">
-            <a:r>
-              <a:t>- Interface implementation: apps/web/app.vue and apps/web/assets/css/main.css</a:t>
+              <a:t>- Actual XiangLens Nuxt interface captured from apps/web in local static-preview mode after the private Lens integration; no model output or private course text was fabricated.</a:t>
+            </a:r>
+          </a:p>
+          <a:p xmlns:a="http://schemas.openxmlformats.org/drawingml/2006/main">
+            <a:r>
+              <a:t>- Interface implementation: apps/web/pages/index.vue and apps/web/assets/css/main.css</a:t>
             </a:r>
           </a:p>
         </p:txBody>
@@ -700,17 +700,12 @@
           </a:p>
           <a:p xmlns:a="http://schemas.openxmlformats.org/drawingml/2006/main">
             <a:r>
-              <a:t>- Architecture and topology: docs/SUBMISSION_BRIEF.md and docs/PRODUCTION_DEPLOYMENT.md</a:t>
-            </a:r>
-          </a:p>
-          <a:p xmlns:a="http://schemas.openxmlformats.org/drawingml/2006/main">
-            <a:r>
-              <a:t>- Workflow implementation: src/xianglens/agent/graph.py</a:t>
-            </a:r>
-          </a:p>
-          <a:p xmlns:a="http://schemas.openxmlformats.org/drawingml/2006/main">
-            <a:r>
-              <a:t>- Session boundary: src/xianglens/auth.py and src/xianglens/main.py</a:t>
+              <a:t>- Agent architecture: docs/SUBMISSION_BRIEF.md</a:t>
+            </a:r>
+          </a:p>
+          <a:p xmlns:a="http://schemas.openxmlformats.org/drawingml/2006/main">
+            <a:r>
+              <a:t>- Runtime-only private mount and safety boundary: docs/PRIVATE_LENS_TOOL.md and src/xianglens/tools/private_lens.py</a:t>
             </a:r>
           </a:p>
         </p:txBody>
@@ -785,17 +780,12 @@
           </a:p>
           <a:p xmlns:a="http://schemas.openxmlformats.org/drawingml/2006/main">
             <a:r>
-              <a:t>- Track 2 capability definitions: Radeon-Cloud-User Guide/2026 AMD AI DevMaster 黑客松赛事说明.md</a:t>
-            </a:r>
-          </a:p>
-          <a:p xmlns:a="http://schemas.openxmlformats.org/drawingml/2006/main">
-            <a:r>
-              <a:t>- Capability-to-evidence mapping: docs/SUBMISSION_BRIEF.md and docs/SUBMISSION_CHECKLIST.md</a:t>
-            </a:r>
-          </a:p>
-          <a:p xmlns:a="http://schemas.openxmlformats.org/drawingml/2006/main">
-            <a:r>
-              <a:t>- Graph implementation: src/xianglens/agent/graph.py</a:t>
+              <a:t>- Bounded workflow implementation: src/xianglens/agent/graph.py</a:t>
+            </a:r>
+          </a:p>
+          <a:p xmlns:a="http://schemas.openxmlformats.org/drawingml/2006/main">
+            <a:r>
+              <a:t>- Private Lens API and typed output contract: src/xianglens/api/routes.py and src/xianglens/schemas.py</a:t>
             </a:r>
           </a:p>
         </p:txBody>
@@ -870,17 +860,12 @@
           </a:p>
           <a:p xmlns:a="http://schemas.openxmlformats.org/drawingml/2006/main">
             <a:r>
-              <a:t>- Model and local topology: docs/SUBMISSION_BRIEF.md</a:t>
-            </a:r>
-          </a:p>
-          <a:p xmlns:a="http://schemas.openxmlformats.org/drawingml/2006/main">
-            <a:r>
-              <a:t>- Production security boundary: docs/PRODUCTION_DEPLOYMENT.md</a:t>
-            </a:r>
-          </a:p>
-          <a:p xmlns:a="http://schemas.openxmlformats.org/drawingml/2006/main">
-            <a:r>
-              <a:t>- llama.cpp client and reasoning budget: src/xianglens/inference/llama_client.py and src/xianglens/config.py</a:t>
+              <a:t>- Deployment boundary: docs/PRODUCTION_DEPLOYMENT.md</a:t>
+            </a:r>
+          </a:p>
+          <a:p xmlns:a="http://schemas.openxmlformats.org/drawingml/2006/main">
+            <a:r>
+              <a:t>- Private tool configuration and service wiring: src/xianglens/config.py and src/xianglens/services.py</a:t>
             </a:r>
           </a:p>
         </p:txBody>
@@ -1045,17 +1030,12 @@
           </a:p>
           <a:p xmlns:a="http://schemas.openxmlformats.org/drawingml/2006/main">
             <a:r>
-              <a:t>- Policy, memory, and deletion behavior: docs/SUBMISSION_BRIEF.md and src/xianglens/agent/graph.py</a:t>
-            </a:r>
-          </a:p>
-          <a:p xmlns:a="http://schemas.openxmlformats.org/drawingml/2006/main">
-            <a:r>
-              <a:t>- Memory persistence: src/xianglens/storage/sqlite_store.py</a:t>
-            </a:r>
-          </a:p>
-          <a:p xmlns:a="http://schemas.openxmlformats.org/drawingml/2006/main">
-            <a:r>
-              <a:t>- Lotus artwork: https://commons.wikimedia.org/wiki/File:Chinese,_%E2%80%98Pink_and_White_Lotus%E2%80%99,_14th_century_China,_Yuan_dynasty_(1279%E2%80%931368),_Hanging_scroll;_mineral_pigments_on_silk,_Kimbell_Art_Museum.jpg (public domain; Kimbell Art Museum)</a:t>
+              <a:t>- Safety policy: docs/SUBMISSION_BRIEF.md</a:t>
+            </a:r>
+          </a:p>
+          <a:p xmlns:a="http://schemas.openxmlformats.org/drawingml/2006/main">
+            <a:r>
+              <a:t>- Runtime-only source, opt-in, output filtering, and rights scan: docs/PRIVATE_LENS_TOOL.md</a:t>
             </a:r>
           </a:p>
         </p:txBody>
@@ -1130,17 +1110,22 @@
           </a:p>
           <a:p xmlns:a="http://schemas.openxmlformats.org/drawingml/2006/main">
             <a:r>
-              <a:t>- Fixture and knowledge counts: docs/SUBMISSION_BRIEF.md and docs/KNOWLEDGE_BASE_DATASET_PLAN.md</a:t>
-            </a:r>
-          </a:p>
-          <a:p xmlns:a="http://schemas.openxmlformats.org/drawingml/2006/main">
-            <a:r>
-              <a:t>- Video plan: docs/DEMO_VIDEO_SCRIPT.md</a:t>
-            </a:r>
-          </a:p>
-          <a:p xmlns:a="http://schemas.openxmlformats.org/drawingml/2006/main">
-            <a:r>
-              <a:t>- Repository verification commands: README.md and docs/SUBMISSION_CHECKLIST.md</a:t>
+              <a:t>- Test inventory: tests/ and data/fixtures/labels.jsonl</a:t>
+            </a:r>
+          </a:p>
+          <a:p xmlns:a="http://schemas.openxmlformats.org/drawingml/2006/main">
+            <a:r>
+              <a:t>- Public RAG cards: data/knowledge/cards.jsonl</a:t>
+            </a:r>
+          </a:p>
+          <a:p xmlns:a="http://schemas.openxmlformats.org/drawingml/2006/main">
+            <a:r>
+              <a:t>- Private Lens integration test: tests/test_private_lens.py</a:t>
+            </a:r>
+          </a:p>
+          <a:p xmlns:a="http://schemas.openxmlformats.org/drawingml/2006/main">
+            <a:r>
+              <a:t>- Recording sequence: docs/DEMO_VIDEO_SCRIPT.md</a:t>
             </a:r>
           </a:p>
         </p:txBody>
@@ -1208,7 +1193,7 @@
   </p:cSld>
   <p:clrMap bg1="lt1" tx1="dk1" bg2="lt2" tx2="dk2" accent1="accent1" accent2="accent2" accent3="accent3" accent4="accent4" accent5="accent5" accent6="accent6" hlink="hlink" folHlink="folHlink"/>
   <p:sldLayoutIdLst>
-    <p:sldLayoutId xmlns:r="http://schemas.openxmlformats.org/officeDocument/2006/relationships" id="2147483649" r:id="R2722ebe53c334f8b"/>
+    <p:sldLayoutId xmlns:r="http://schemas.openxmlformats.org/officeDocument/2006/relationships" id="2147483649" r:id="R0099b5a1cfd542f3"/>
   </p:sldLayoutIdLst>
   <p:txStyles>
     <p:titleStyle>
@@ -1820,6 +1805,7 @@
           <a:lstStyle xmlns:a="http://schemas.openxmlformats.org/drawingml/2006/main"/>
           <a:p xmlns:a="http://schemas.openxmlformats.org/drawingml/2006/main">
             <a:pPr algn="l">
+              <a:buNone/>
               <a:defRPr sz="1650" b="1">
                 <a:solidFill>
                   <a:srgbClr val="E51B23"/>
@@ -1878,6 +1864,7 @@
           <a:lstStyle xmlns:a="http://schemas.openxmlformats.org/drawingml/2006/main"/>
           <a:p xmlns:a="http://schemas.openxmlformats.org/drawingml/2006/main">
             <a:pPr algn="l">
+              <a:buNone/>
               <a:defRPr sz="6300" b="1">
                 <a:solidFill>
                   <a:srgbClr val="111111"/>
@@ -1936,6 +1923,7 @@
           <a:lstStyle xmlns:a="http://schemas.openxmlformats.org/drawingml/2006/main"/>
           <a:p xmlns:a="http://schemas.openxmlformats.org/drawingml/2006/main">
             <a:pPr algn="l">
+              <a:buNone/>
               <a:defRPr sz="2250" b="0">
                 <a:solidFill>
                   <a:srgbClr val="5F6368"/>
@@ -1959,6 +1947,7 @@
           </a:p>
           <a:p xmlns:a="http://schemas.openxmlformats.org/drawingml/2006/main">
             <a:pPr algn="l">
+              <a:buNone/>
               <a:defRPr sz="2250" b="0">
                 <a:solidFill>
                   <a:srgbClr val="5F6368"/>
@@ -2017,6 +2006,7 @@
           <a:lstStyle xmlns:a="http://schemas.openxmlformats.org/drawingml/2006/main"/>
           <a:p xmlns:a="http://schemas.openxmlformats.org/drawingml/2006/main">
             <a:pPr algn="l">
+              <a:buNone/>
               <a:defRPr sz="1275" b="1">
                 <a:solidFill>
                   <a:srgbClr val="5F6368"/>
@@ -2075,6 +2065,7 @@
           <a:lstStyle xmlns:a="http://schemas.openxmlformats.org/drawingml/2006/main"/>
           <a:p xmlns:a="http://schemas.openxmlformats.org/drawingml/2006/main">
             <a:pPr algn="ctr">
+              <a:buNone/>
               <a:defRPr sz="6150" b="1">
                 <a:solidFill>
                   <a:srgbClr val="FFFFFF"/>
@@ -2193,6 +2184,7 @@
           <a:lstStyle xmlns:a="http://schemas.openxmlformats.org/drawingml/2006/main"/>
           <a:p xmlns:a="http://schemas.openxmlformats.org/drawingml/2006/main">
             <a:pPr algn="l">
+              <a:buNone/>
               <a:defRPr sz="2925" b="1">
                 <a:solidFill>
                   <a:srgbClr val="111111"/>
@@ -2251,6 +2243,7 @@
           <a:lstStyle xmlns:a="http://schemas.openxmlformats.org/drawingml/2006/main"/>
           <a:p xmlns:a="http://schemas.openxmlformats.org/drawingml/2006/main">
             <a:pPr algn="l">
+              <a:buNone/>
               <a:defRPr sz="2025" b="1">
                 <a:solidFill>
                   <a:srgbClr val="111111"/>
@@ -2309,6 +2302,7 @@
           <a:lstStyle xmlns:a="http://schemas.openxmlformats.org/drawingml/2006/main"/>
           <a:p xmlns:a="http://schemas.openxmlformats.org/drawingml/2006/main">
             <a:pPr algn="l">
+              <a:buNone/>
               <a:defRPr sz="1650" b="0">
                 <a:solidFill>
                   <a:srgbClr val="5F6368"/>
@@ -2337,6 +2331,7 @@
           </a:p>
           <a:p xmlns:a="http://schemas.openxmlformats.org/drawingml/2006/main">
             <a:pPr algn="l">
+              <a:buNone/>
               <a:defRPr sz="1650" b="0">
                 <a:solidFill>
                   <a:srgbClr val="5F6368"/>
@@ -2365,6 +2360,7 @@
           </a:p>
           <a:p xmlns:a="http://schemas.openxmlformats.org/drawingml/2006/main">
             <a:pPr algn="l">
+              <a:buNone/>
               <a:defRPr sz="1650" b="0">
                 <a:solidFill>
                   <a:srgbClr val="5F6368"/>
@@ -2423,6 +2419,7 @@
           <a:lstStyle xmlns:a="http://schemas.openxmlformats.org/drawingml/2006/main"/>
           <a:p xmlns:a="http://schemas.openxmlformats.org/drawingml/2006/main">
             <a:pPr algn="l">
+              <a:buNone/>
               <a:defRPr sz="1350" b="1">
                 <a:solidFill>
                   <a:srgbClr val="E51B23"/>
@@ -2483,14 +2480,14 @@
       </p:sp>
       <p:pic>
         <p:nvPicPr>
-          <p:cNvPr id="19" name=""/>
+          <p:cNvPr id="22" name=""/>
           <p:cNvPicPr>
             <a:picLocks xmlns:a="http://schemas.openxmlformats.org/drawingml/2006/main" noChangeAspect="1"/>
           </p:cNvPicPr>
           <p:nvPr/>
         </p:nvPicPr>
         <p:blipFill>
-          <a:blip xmlns:r="http://schemas.openxmlformats.org/officeDocument/2006/relationships" xmlns:a="http://schemas.openxmlformats.org/drawingml/2006/main" r:embed="R110d0f3686e04e87"/>
+          <a:blip xmlns:r="http://schemas.openxmlformats.org/officeDocument/2006/relationships" xmlns:a="http://schemas.openxmlformats.org/drawingml/2006/main" r:embed="R373a40c3ead14636"/>
           <a:srcRect xmlns:a="http://schemas.openxmlformats.org/drawingml/2006/main" l="0" t="0" r="0" b="0"/>
           <a:stretch xmlns:a="http://schemas.openxmlformats.org/drawingml/2006/main">
             <a:fillRect l="0" t="0" r="0" b="0"/>
@@ -2508,14 +2505,14 @@
       </p:pic>
       <p:pic>
         <p:nvPicPr>
-          <p:cNvPr id="20" name=""/>
+          <p:cNvPr id="23" name=""/>
           <p:cNvPicPr>
             <a:picLocks xmlns:a="http://schemas.openxmlformats.org/drawingml/2006/main" noChangeAspect="1"/>
           </p:cNvPicPr>
           <p:nvPr/>
         </p:nvPicPr>
         <p:blipFill>
-          <a:blip xmlns:r="http://schemas.openxmlformats.org/officeDocument/2006/relationships" xmlns:a="http://schemas.openxmlformats.org/drawingml/2006/main" r:embed="Raf5aeb267aaf4e2e"/>
+          <a:blip xmlns:r="http://schemas.openxmlformats.org/officeDocument/2006/relationships" xmlns:a="http://schemas.openxmlformats.org/drawingml/2006/main" r:embed="Ra8249ae56b7b4589"/>
           <a:srcRect xmlns:a="http://schemas.openxmlformats.org/drawingml/2006/main" l="0" t="0" r="0" b="0"/>
           <a:stretch xmlns:a="http://schemas.openxmlformats.org/drawingml/2006/main">
             <a:fillRect l="0" t="0" r="0" b="0"/>
@@ -2566,6 +2563,7 @@
           <a:lstStyle xmlns:a="http://schemas.openxmlformats.org/drawingml/2006/main"/>
           <a:p xmlns:a="http://schemas.openxmlformats.org/drawingml/2006/main">
             <a:pPr algn="ctr">
+              <a:buNone/>
               <a:defRPr sz="1200" b="1">
                 <a:solidFill>
                   <a:srgbClr val="111111"/>
@@ -2589,6 +2587,7 @@
           </a:p>
           <a:p xmlns:a="http://schemas.openxmlformats.org/drawingml/2006/main">
             <a:pPr algn="ctr">
+              <a:buNone/>
               <a:defRPr sz="1200" b="1">
                 <a:solidFill>
                   <a:srgbClr val="111111"/>
@@ -2647,6 +2646,7 @@
           <a:lstStyle xmlns:a="http://schemas.openxmlformats.org/drawingml/2006/main"/>
           <a:p xmlns:a="http://schemas.openxmlformats.org/drawingml/2006/main">
             <a:pPr algn="ctr">
+              <a:buNone/>
               <a:defRPr sz="1200" b="1">
                 <a:solidFill>
                   <a:srgbClr val="E51B23"/>
@@ -2670,6 +2670,7 @@
           </a:p>
           <a:p xmlns:a="http://schemas.openxmlformats.org/drawingml/2006/main">
             <a:pPr algn="ctr">
+              <a:buNone/>
               <a:defRPr sz="1200" b="1">
                 <a:solidFill>
                   <a:srgbClr val="E51B23"/>
@@ -2728,6 +2729,7 @@
           <a:lstStyle xmlns:a="http://schemas.openxmlformats.org/drawingml/2006/main"/>
           <a:p xmlns:a="http://schemas.openxmlformats.org/drawingml/2006/main">
             <a:pPr algn="r">
+              <a:buNone/>
               <a:defRPr sz="1050" b="0">
                 <a:solidFill>
                   <a:srgbClr val="5F6368"/>
@@ -2786,6 +2788,7 @@
           <a:lstStyle xmlns:a="http://schemas.openxmlformats.org/drawingml/2006/main"/>
           <a:p xmlns:a="http://schemas.openxmlformats.org/drawingml/2006/main">
             <a:pPr algn="l">
+              <a:buNone/>
               <a:defRPr sz="975" b="0">
                 <a:solidFill>
                   <a:srgbClr val="5F6368"/>
@@ -2904,6 +2907,7 @@
           <a:lstStyle xmlns:a="http://schemas.openxmlformats.org/drawingml/2006/main"/>
           <a:p xmlns:a="http://schemas.openxmlformats.org/drawingml/2006/main">
             <a:pPr algn="l">
+              <a:buNone/>
               <a:defRPr sz="2925" b="1">
                 <a:solidFill>
                   <a:srgbClr val="111111"/>
@@ -2962,21 +2966,21 @@
       </p:sp>
       <p:pic>
         <p:nvPicPr>
-          <p:cNvPr id="19" name=""/>
+          <p:cNvPr id="41" name=""/>
           <p:cNvPicPr>
             <a:picLocks xmlns:a="http://schemas.openxmlformats.org/drawingml/2006/main" noChangeAspect="1"/>
           </p:cNvPicPr>
           <p:nvPr/>
         </p:nvPicPr>
         <p:blipFill>
-          <a:blip xmlns:r="http://schemas.openxmlformats.org/officeDocument/2006/relationships" xmlns:a="http://schemas.openxmlformats.org/drawingml/2006/main" r:embed="R7de50ad9fe37498d"/>
+          <a:blip xmlns:r="http://schemas.openxmlformats.org/officeDocument/2006/relationships" xmlns:a="http://schemas.openxmlformats.org/drawingml/2006/main" r:embed="Rbac8c5203a6c4a17"/>
           <a:srcRect xmlns:a="http://schemas.openxmlformats.org/drawingml/2006/main" l="0" t="0" r="0" b="0"/>
           <a:stretch xmlns:a="http://schemas.openxmlformats.org/drawingml/2006/main">
             <a:fillRect l="0" t="0" r="0" b="0"/>
           </a:stretch>
         </p:blipFill>
         <p:spPr>
-          <a:xfrm xmlns:a="http://schemas.openxmlformats.org/drawingml/2006/main">
+          <a:xfrm xmlns:a="http://schemas.openxmlformats.org/drawingml/2006/main" flipH="0" flipV="0">
             <a:off x="400050" y="1419225"/>
             <a:ext cx="8229600" cy="4629150"/>
           </a:xfrm>
@@ -3020,6 +3024,7 @@
           <a:lstStyle xmlns:a="http://schemas.openxmlformats.org/drawingml/2006/main"/>
           <a:p xmlns:a="http://schemas.openxmlformats.org/drawingml/2006/main">
             <a:pPr algn="l">
+              <a:buNone/>
               <a:defRPr sz="1125" b="1">
                 <a:solidFill>
                   <a:srgbClr val="E51B23"/>
@@ -3078,6 +3083,7 @@
           <a:lstStyle xmlns:a="http://schemas.openxmlformats.org/drawingml/2006/main"/>
           <a:p xmlns:a="http://schemas.openxmlformats.org/drawingml/2006/main">
             <a:pPr algn="l">
+              <a:buNone/>
               <a:defRPr sz="1500" b="1">
                 <a:solidFill>
                   <a:srgbClr val="111111"/>
@@ -3103,7 +3109,7 @@
       </p:sp>
       <p:cxnSp>
         <p:nvCxnSpPr>
-          <p:cNvPr id="22" name="ui-rule-0"/>
+          <p:cNvPr id="44" name="ui-rule-0"/>
           <p:cNvCxnSpPr/>
           <p:nvPr/>
         </p:nvCxnSpPr>
@@ -3158,6 +3164,7 @@
           <a:lstStyle xmlns:a="http://schemas.openxmlformats.org/drawingml/2006/main"/>
           <a:p xmlns:a="http://schemas.openxmlformats.org/drawingml/2006/main">
             <a:pPr algn="l">
+              <a:buNone/>
               <a:defRPr sz="1125" b="1">
                 <a:solidFill>
                   <a:srgbClr val="E51B23"/>
@@ -3216,6 +3223,7 @@
           <a:lstStyle xmlns:a="http://schemas.openxmlformats.org/drawingml/2006/main"/>
           <a:p xmlns:a="http://schemas.openxmlformats.org/drawingml/2006/main">
             <a:pPr algn="l">
+              <a:buNone/>
               <a:defRPr sz="1500" b="1">
                 <a:solidFill>
                   <a:srgbClr val="111111"/>
@@ -3241,7 +3249,7 @@
       </p:sp>
       <p:cxnSp>
         <p:nvCxnSpPr>
-          <p:cNvPr id="25" name="ui-rule-1"/>
+          <p:cNvPr id="47" name="ui-rule-1"/>
           <p:cNvCxnSpPr/>
           <p:nvPr/>
         </p:nvCxnSpPr>
@@ -3296,6 +3304,7 @@
           <a:lstStyle xmlns:a="http://schemas.openxmlformats.org/drawingml/2006/main"/>
           <a:p xmlns:a="http://schemas.openxmlformats.org/drawingml/2006/main">
             <a:pPr algn="l">
+              <a:buNone/>
               <a:defRPr sz="1125" b="1">
                 <a:solidFill>
                   <a:srgbClr val="E51B23"/>
@@ -3314,7 +3323,7 @@
                 <a:ea typeface="Helvetica Neue"/>
                 <a:cs typeface="Helvetica Neue"/>
               </a:rPr>
-              <a:t>03 · TRACE</a:t>
+              <a:t>03 · TRACE + PRIVATE</a:t>
             </a:r>
           </a:p>
         </p:txBody>
@@ -3354,6 +3363,7 @@
           <a:lstStyle xmlns:a="http://schemas.openxmlformats.org/drawingml/2006/main"/>
           <a:p xmlns:a="http://schemas.openxmlformats.org/drawingml/2006/main">
             <a:pPr algn="l">
+              <a:buNone/>
               <a:defRPr sz="1500" b="1">
                 <a:solidFill>
                   <a:srgbClr val="111111"/>
@@ -3372,7 +3382,7 @@
                 <a:ea typeface="Helvetica Neue"/>
                 <a:cs typeface="Helvetica Neue"/>
               </a:rPr>
-              <a:t>Retrieval, memory, deletion, and inference ownership stay visible.</a:t>
+              <a:t>Retrieval, private Tool, memory, deletion, and ownership stay visible.</a:t>
             </a:r>
           </a:p>
         </p:txBody>
@@ -3412,6 +3422,7 @@
           <a:lstStyle xmlns:a="http://schemas.openxmlformats.org/drawingml/2006/main"/>
           <a:p xmlns:a="http://schemas.openxmlformats.org/drawingml/2006/main">
             <a:pPr algn="r">
+              <a:buNone/>
               <a:defRPr sz="900" b="1">
                 <a:solidFill>
                   <a:srgbClr val="5F6368"/>
@@ -3470,6 +3481,7 @@
           <a:lstStyle xmlns:a="http://schemas.openxmlformats.org/drawingml/2006/main"/>
           <a:p xmlns:a="http://schemas.openxmlformats.org/drawingml/2006/main">
             <a:pPr algn="r">
+              <a:buNone/>
               <a:defRPr sz="1050" b="0">
                 <a:solidFill>
                   <a:srgbClr val="5F6368"/>
@@ -3528,6 +3540,7 @@
           <a:lstStyle xmlns:a="http://schemas.openxmlformats.org/drawingml/2006/main"/>
           <a:p xmlns:a="http://schemas.openxmlformats.org/drawingml/2006/main">
             <a:pPr algn="l">
+              <a:buNone/>
               <a:defRPr sz="975" b="0">
                 <a:solidFill>
                   <a:srgbClr val="5F6368"/>
@@ -3646,6 +3659,7 @@
           <a:lstStyle xmlns:a="http://schemas.openxmlformats.org/drawingml/2006/main"/>
           <a:p xmlns:a="http://schemas.openxmlformats.org/drawingml/2006/main">
             <a:pPr algn="l">
+              <a:buNone/>
               <a:defRPr sz="2925" b="1">
                 <a:solidFill>
                   <a:srgbClr val="111111"/>
@@ -3671,7 +3685,7 @@
       </p:sp>
       <p:cxnSp>
         <p:nvCxnSpPr>
-          <p:cNvPr id="41" name="browser-api"/>
+          <p:cNvPr id="59" name="browser-api"/>
           <p:cNvCxnSpPr/>
           <p:nvPr/>
         </p:nvCxnSpPr>
@@ -3693,7 +3707,7 @@
       </p:cxnSp>
       <p:cxnSp>
         <p:nvCxnSpPr>
-          <p:cNvPr id="42" name="api-graph"/>
+          <p:cNvPr id="60" name="api-graph"/>
           <p:cNvCxnSpPr/>
           <p:nvPr/>
         </p:nvCxnSpPr>
@@ -3715,7 +3729,7 @@
       </p:cxnSp>
       <p:cxnSp>
         <p:nvCxnSpPr>
-          <p:cNvPr id="43" name="graph-model"/>
+          <p:cNvPr id="61" name="graph-model"/>
           <p:cNvCxnSpPr/>
           <p:nvPr/>
         </p:nvCxnSpPr>
@@ -3737,7 +3751,7 @@
       </p:cxnSp>
       <p:cxnSp>
         <p:nvCxnSpPr>
-          <p:cNvPr id="44" name="model-gpu"/>
+          <p:cNvPr id="62" name="model-gpu"/>
           <p:cNvCxnSpPr/>
           <p:nvPr/>
         </p:nvCxnSpPr>
@@ -3759,7 +3773,7 @@
       </p:cxnSp>
       <p:cxnSp>
         <p:nvCxnSpPr>
-          <p:cNvPr id="45" name="graph-tools"/>
+          <p:cNvPr id="63" name="graph-tools"/>
           <p:cNvCxnSpPr/>
           <p:nvPr/>
         </p:nvCxnSpPr>
@@ -3781,7 +3795,7 @@
       </p:cxnSp>
       <p:cxnSp>
         <p:nvCxnSpPr>
-          <p:cNvPr id="46" name="graph-rag"/>
+          <p:cNvPr id="64" name="graph-rag"/>
           <p:cNvCxnSpPr/>
           <p:nvPr/>
         </p:nvCxnSpPr>
@@ -3803,7 +3817,7 @@
       </p:cxnSp>
       <p:cxnSp>
         <p:nvCxnSpPr>
-          <p:cNvPr id="47" name="graph-memory"/>
+          <p:cNvPr id="65" name="graph-memory"/>
           <p:cNvCxnSpPr/>
           <p:nvPr/>
         </p:nvCxnSpPr>
@@ -3893,6 +3907,7 @@
           <a:lstStyle xmlns:a="http://schemas.openxmlformats.org/drawingml/2006/main"/>
           <a:p xmlns:a="http://schemas.openxmlformats.org/drawingml/2006/main">
             <a:pPr algn="ctr">
+              <a:buNone/>
               <a:defRPr sz="1275" b="1">
                 <a:solidFill>
                   <a:srgbClr val="111111"/>
@@ -3951,6 +3966,7 @@
           <a:lstStyle xmlns:a="http://schemas.openxmlformats.org/drawingml/2006/main"/>
           <a:p xmlns:a="http://schemas.openxmlformats.org/drawingml/2006/main">
             <a:pPr algn="ctr">
+              <a:buNone/>
               <a:defRPr sz="975" b="0">
                 <a:solidFill>
                   <a:srgbClr val="5F6368"/>
@@ -4044,6 +4060,7 @@
           <a:lstStyle xmlns:a="http://schemas.openxmlformats.org/drawingml/2006/main"/>
           <a:p xmlns:a="http://schemas.openxmlformats.org/drawingml/2006/main">
             <a:pPr algn="ctr">
+              <a:buNone/>
               <a:defRPr sz="1275" b="1">
                 <a:solidFill>
                   <a:srgbClr val="111111"/>
@@ -4102,6 +4119,7 @@
           <a:lstStyle xmlns:a="http://schemas.openxmlformats.org/drawingml/2006/main"/>
           <a:p xmlns:a="http://schemas.openxmlformats.org/drawingml/2006/main">
             <a:pPr algn="ctr">
+              <a:buNone/>
               <a:defRPr sz="975" b="0">
                 <a:solidFill>
                   <a:srgbClr val="5F6368"/>
@@ -4195,6 +4213,7 @@
           <a:lstStyle xmlns:a="http://schemas.openxmlformats.org/drawingml/2006/main"/>
           <a:p xmlns:a="http://schemas.openxmlformats.org/drawingml/2006/main">
             <a:pPr algn="ctr">
+              <a:buNone/>
               <a:defRPr sz="1275" b="1">
                 <a:solidFill>
                   <a:srgbClr val="111111"/>
@@ -4253,6 +4272,7 @@
           <a:lstStyle xmlns:a="http://schemas.openxmlformats.org/drawingml/2006/main"/>
           <a:p xmlns:a="http://schemas.openxmlformats.org/drawingml/2006/main">
             <a:pPr algn="ctr">
+              <a:buNone/>
               <a:defRPr sz="975" b="0">
                 <a:solidFill>
                   <a:srgbClr val="5F6368"/>
@@ -4346,6 +4366,7 @@
           <a:lstStyle xmlns:a="http://schemas.openxmlformats.org/drawingml/2006/main"/>
           <a:p xmlns:a="http://schemas.openxmlformats.org/drawingml/2006/main">
             <a:pPr algn="ctr">
+              <a:buNone/>
               <a:defRPr sz="1275" b="1">
                 <a:solidFill>
                   <a:srgbClr val="111111"/>
@@ -4404,6 +4425,7 @@
           <a:lstStyle xmlns:a="http://schemas.openxmlformats.org/drawingml/2006/main"/>
           <a:p xmlns:a="http://schemas.openxmlformats.org/drawingml/2006/main">
             <a:pPr algn="ctr">
+              <a:buNone/>
               <a:defRPr sz="975" b="0">
                 <a:solidFill>
                   <a:srgbClr val="5F6368"/>
@@ -4497,6 +4519,7 @@
           <a:lstStyle xmlns:a="http://schemas.openxmlformats.org/drawingml/2006/main"/>
           <a:p xmlns:a="http://schemas.openxmlformats.org/drawingml/2006/main">
             <a:pPr algn="ctr">
+              <a:buNone/>
               <a:defRPr sz="1275" b="1">
                 <a:solidFill>
                   <a:srgbClr val="111111"/>
@@ -4555,6 +4578,7 @@
           <a:lstStyle xmlns:a="http://schemas.openxmlformats.org/drawingml/2006/main"/>
           <a:p xmlns:a="http://schemas.openxmlformats.org/drawingml/2006/main">
             <a:pPr algn="ctr">
+              <a:buNone/>
               <a:defRPr sz="975" b="0">
                 <a:solidFill>
                   <a:srgbClr val="5F6368"/>
@@ -4648,6 +4672,7 @@
           <a:lstStyle xmlns:a="http://schemas.openxmlformats.org/drawingml/2006/main"/>
           <a:p xmlns:a="http://schemas.openxmlformats.org/drawingml/2006/main">
             <a:pPr algn="ctr">
+              <a:buNone/>
               <a:defRPr sz="1575" b="1">
                 <a:solidFill>
                   <a:srgbClr val="111111"/>
@@ -4706,6 +4731,7 @@
           <a:lstStyle xmlns:a="http://schemas.openxmlformats.org/drawingml/2006/main"/>
           <a:p xmlns:a="http://schemas.openxmlformats.org/drawingml/2006/main">
             <a:pPr algn="ctr">
+              <a:buNone/>
               <a:defRPr sz="1050" b="0">
                 <a:solidFill>
                   <a:srgbClr val="5F6368"/>
@@ -4799,6 +4825,7 @@
           <a:lstStyle xmlns:a="http://schemas.openxmlformats.org/drawingml/2006/main"/>
           <a:p xmlns:a="http://schemas.openxmlformats.org/drawingml/2006/main">
             <a:pPr algn="ctr">
+              <a:buNone/>
               <a:defRPr sz="1575" b="1">
                 <a:solidFill>
                   <a:srgbClr val="111111"/>
@@ -4817,7 +4844,7 @@
                 <a:ea typeface="Helvetica Neue"/>
                 <a:cs typeface="Helvetica Neue"/>
               </a:rPr>
-              <a:t>Milvus Lite</a:t>
+              <a:t>Context engines</a:t>
             </a:r>
           </a:p>
         </p:txBody>
@@ -4857,6 +4884,7 @@
           <a:lstStyle xmlns:a="http://schemas.openxmlformats.org/drawingml/2006/main"/>
           <a:p xmlns:a="http://schemas.openxmlformats.org/drawingml/2006/main">
             <a:pPr algn="ctr">
+              <a:buNone/>
               <a:defRPr sz="1050" b="0">
                 <a:solidFill>
                   <a:srgbClr val="5F6368"/>
@@ -4875,7 +4903,7 @@
                 <a:ea typeface="Helvetica Neue"/>
                 <a:cs typeface="Helvetica Neue"/>
               </a:rPr>
-              <a:t>Top-K evidence · 4 Lens Packs</a:t>
+              <a:t>Milvus Top-K · opt-in private Lens</a:t>
             </a:r>
           </a:p>
         </p:txBody>
@@ -4950,6 +4978,7 @@
           <a:lstStyle xmlns:a="http://schemas.openxmlformats.org/drawingml/2006/main"/>
           <a:p xmlns:a="http://schemas.openxmlformats.org/drawingml/2006/main">
             <a:pPr algn="ctr">
+              <a:buNone/>
               <a:defRPr sz="1575" b="1">
                 <a:solidFill>
                   <a:srgbClr val="111111"/>
@@ -5008,6 +5037,7 @@
           <a:lstStyle xmlns:a="http://schemas.openxmlformats.org/drawingml/2006/main"/>
           <a:p xmlns:a="http://schemas.openxmlformats.org/drawingml/2006/main">
             <a:pPr algn="ctr">
+              <a:buNone/>
               <a:defRPr sz="1050" b="0">
                 <a:solidFill>
                   <a:srgbClr val="5F6368"/>
@@ -5066,6 +5096,7 @@
           <a:lstStyle xmlns:a="http://schemas.openxmlformats.org/drawingml/2006/main"/>
           <a:p xmlns:a="http://schemas.openxmlformats.org/drawingml/2006/main">
             <a:pPr algn="l">
+              <a:buNone/>
               <a:defRPr sz="1050" b="1">
                 <a:solidFill>
                   <a:srgbClr val="5F6368"/>
@@ -5124,6 +5155,7 @@
           <a:lstStyle xmlns:a="http://schemas.openxmlformats.org/drawingml/2006/main"/>
           <a:p xmlns:a="http://schemas.openxmlformats.org/drawingml/2006/main">
             <a:pPr algn="l">
+              <a:buNone/>
               <a:defRPr sz="1050" b="1">
                 <a:solidFill>
                   <a:srgbClr val="E51B23"/>
@@ -5182,6 +5214,7 @@
           <a:lstStyle xmlns:a="http://schemas.openxmlformats.org/drawingml/2006/main"/>
           <a:p xmlns:a="http://schemas.openxmlformats.org/drawingml/2006/main">
             <a:pPr algn="ctr">
+              <a:buNone/>
               <a:defRPr sz="1275" b="1">
                 <a:solidFill>
                   <a:srgbClr val="111111"/>
@@ -5200,7 +5233,7 @@
                 <a:ea typeface="Helvetica Neue"/>
                 <a:cs typeface="Helvetica Neue"/>
               </a:rPr>
-              <a:t>Only FastAPI is exposed. The model endpoint, Milvus, SQLite, uploads, and permanent key stay private.</a:t>
+              <a:t>FastAPI alone is exposed; model, Milvus, private Lens, SQLite, uploads, and permanent key stay private.</a:t>
             </a:r>
           </a:p>
         </p:txBody>
@@ -5240,6 +5273,7 @@
           <a:lstStyle xmlns:a="http://schemas.openxmlformats.org/drawingml/2006/main"/>
           <a:p xmlns:a="http://schemas.openxmlformats.org/drawingml/2006/main">
             <a:pPr algn="r">
+              <a:buNone/>
               <a:defRPr sz="1050" b="0">
                 <a:solidFill>
                   <a:srgbClr val="5F6368"/>
@@ -5298,6 +5332,7 @@
           <a:lstStyle xmlns:a="http://schemas.openxmlformats.org/drawingml/2006/main"/>
           <a:p xmlns:a="http://schemas.openxmlformats.org/drawingml/2006/main">
             <a:pPr algn="l">
+              <a:buNone/>
               <a:defRPr sz="975" b="0">
                 <a:solidFill>
                   <a:srgbClr val="5F6368"/>
@@ -5416,6 +5451,7 @@
           <a:lstStyle xmlns:a="http://schemas.openxmlformats.org/drawingml/2006/main"/>
           <a:p xmlns:a="http://schemas.openxmlformats.org/drawingml/2006/main">
             <a:pPr algn="l">
+              <a:buNone/>
               <a:defRPr sz="2925" b="1">
                 <a:solidFill>
                   <a:srgbClr val="111111"/>
@@ -5441,7 +5477,7 @@
       </p:sp>
       <p:cxnSp>
         <p:nvCxnSpPr>
-          <p:cNvPr id="29" name="capability-spine"/>
+          <p:cNvPr id="35" name="capability-spine"/>
           <p:cNvCxnSpPr/>
           <p:nvPr/>
         </p:nvCxnSpPr>
@@ -5527,6 +5563,7 @@
           <a:lstStyle xmlns:a="http://schemas.openxmlformats.org/drawingml/2006/main"/>
           <a:p xmlns:a="http://schemas.openxmlformats.org/drawingml/2006/main">
             <a:pPr algn="ctr">
+              <a:buNone/>
               <a:defRPr sz="1125" b="1">
                 <a:solidFill>
                   <a:srgbClr val="FFFFFF"/>
@@ -5585,6 +5622,7 @@
           <a:lstStyle xmlns:a="http://schemas.openxmlformats.org/drawingml/2006/main"/>
           <a:p xmlns:a="http://schemas.openxmlformats.org/drawingml/2006/main">
             <a:pPr algn="ctr">
+              <a:buNone/>
               <a:defRPr sz="2100" b="1">
                 <a:solidFill>
                   <a:srgbClr val="111111"/>
@@ -5643,6 +5681,7 @@
           <a:lstStyle xmlns:a="http://schemas.openxmlformats.org/drawingml/2006/main"/>
           <a:p xmlns:a="http://schemas.openxmlformats.org/drawingml/2006/main">
             <a:pPr algn="ctr">
+              <a:buNone/>
               <a:defRPr sz="1275" b="0">
                 <a:solidFill>
                   <a:srgbClr val="5F6368"/>
@@ -5666,6 +5705,7 @@
           </a:p>
           <a:p xmlns:a="http://schemas.openxmlformats.org/drawingml/2006/main">
             <a:pPr algn="ctr">
+              <a:buNone/>
               <a:defRPr sz="1275" b="0">
                 <a:solidFill>
                   <a:srgbClr val="5F6368"/>
@@ -5755,6 +5795,7 @@
           <a:lstStyle xmlns:a="http://schemas.openxmlformats.org/drawingml/2006/main"/>
           <a:p xmlns:a="http://schemas.openxmlformats.org/drawingml/2006/main">
             <a:pPr algn="ctr">
+              <a:buNone/>
               <a:defRPr sz="1125" b="1">
                 <a:solidFill>
                   <a:srgbClr val="FFFFFF"/>
@@ -5813,6 +5854,7 @@
           <a:lstStyle xmlns:a="http://schemas.openxmlformats.org/drawingml/2006/main"/>
           <a:p xmlns:a="http://schemas.openxmlformats.org/drawingml/2006/main">
             <a:pPr algn="ctr">
+              <a:buNone/>
               <a:defRPr sz="2100" b="1">
                 <a:solidFill>
                   <a:srgbClr val="111111"/>
@@ -5871,6 +5913,7 @@
           <a:lstStyle xmlns:a="http://schemas.openxmlformats.org/drawingml/2006/main"/>
           <a:p xmlns:a="http://schemas.openxmlformats.org/drawingml/2006/main">
             <a:pPr algn="ctr">
+              <a:buNone/>
               <a:defRPr sz="1275" b="0">
                 <a:solidFill>
                   <a:srgbClr val="5F6368"/>
@@ -5894,6 +5937,7 @@
           </a:p>
           <a:p xmlns:a="http://schemas.openxmlformats.org/drawingml/2006/main">
             <a:pPr algn="ctr">
+              <a:buNone/>
               <a:defRPr sz="1275" b="0">
                 <a:solidFill>
                   <a:srgbClr val="5F6368"/>
@@ -5912,7 +5956,7 @@
                 <a:ea typeface="Helvetica Neue"/>
                 <a:cs typeface="Helvetica Neue"/>
               </a:rPr>
-              <a:t>and safe-copy export</a:t>
+              <a:t>private Lens, safe copy</a:t>
             </a:r>
           </a:p>
         </p:txBody>
@@ -5983,6 +6027,7 @@
           <a:lstStyle xmlns:a="http://schemas.openxmlformats.org/drawingml/2006/main"/>
           <a:p xmlns:a="http://schemas.openxmlformats.org/drawingml/2006/main">
             <a:pPr algn="ctr">
+              <a:buNone/>
               <a:defRPr sz="1125" b="1">
                 <a:solidFill>
                   <a:srgbClr val="FFFFFF"/>
@@ -6041,6 +6086,7 @@
           <a:lstStyle xmlns:a="http://schemas.openxmlformats.org/drawingml/2006/main"/>
           <a:p xmlns:a="http://schemas.openxmlformats.org/drawingml/2006/main">
             <a:pPr algn="ctr">
+              <a:buNone/>
               <a:defRPr sz="2100" b="1">
                 <a:solidFill>
                   <a:srgbClr val="111111"/>
@@ -6099,6 +6145,7 @@
           <a:lstStyle xmlns:a="http://schemas.openxmlformats.org/drawingml/2006/main"/>
           <a:p xmlns:a="http://schemas.openxmlformats.org/drawingml/2006/main">
             <a:pPr algn="ctr">
+              <a:buNone/>
               <a:defRPr sz="1275" b="0">
                 <a:solidFill>
                   <a:srgbClr val="5F6368"/>
@@ -6122,6 +6169,7 @@
           </a:p>
           <a:p xmlns:a="http://schemas.openxmlformats.org/drawingml/2006/main">
             <a:pPr algn="ctr">
+              <a:buNone/>
               <a:defRPr sz="1275" b="0">
                 <a:solidFill>
                   <a:srgbClr val="5F6368"/>
@@ -6211,6 +6259,7 @@
           <a:lstStyle xmlns:a="http://schemas.openxmlformats.org/drawingml/2006/main"/>
           <a:p xmlns:a="http://schemas.openxmlformats.org/drawingml/2006/main">
             <a:pPr algn="ctr">
+              <a:buNone/>
               <a:defRPr sz="1125" b="1">
                 <a:solidFill>
                   <a:srgbClr val="FFFFFF"/>
@@ -6269,6 +6318,7 @@
           <a:lstStyle xmlns:a="http://schemas.openxmlformats.org/drawingml/2006/main"/>
           <a:p xmlns:a="http://schemas.openxmlformats.org/drawingml/2006/main">
             <a:pPr algn="ctr">
+              <a:buNone/>
               <a:defRPr sz="2100" b="1">
                 <a:solidFill>
                   <a:srgbClr val="111111"/>
@@ -6327,6 +6377,7 @@
           <a:lstStyle xmlns:a="http://schemas.openxmlformats.org/drawingml/2006/main"/>
           <a:p xmlns:a="http://schemas.openxmlformats.org/drawingml/2006/main">
             <a:pPr algn="ctr">
+              <a:buNone/>
               <a:defRPr sz="1275" b="0">
                 <a:solidFill>
                   <a:srgbClr val="5F6368"/>
@@ -6350,6 +6401,7 @@
           </a:p>
           <a:p xmlns:a="http://schemas.openxmlformats.org/drawingml/2006/main">
             <a:pPr algn="ctr">
+              <a:buNone/>
               <a:defRPr sz="1275" b="0">
                 <a:solidFill>
                   <a:srgbClr val="5F6368"/>
@@ -6439,6 +6491,7 @@
           <a:lstStyle xmlns:a="http://schemas.openxmlformats.org/drawingml/2006/main"/>
           <a:p xmlns:a="http://schemas.openxmlformats.org/drawingml/2006/main">
             <a:pPr algn="ctr">
+              <a:buNone/>
               <a:defRPr sz="1125" b="1">
                 <a:solidFill>
                   <a:srgbClr val="FFFFFF"/>
@@ -6497,6 +6550,7 @@
           <a:lstStyle xmlns:a="http://schemas.openxmlformats.org/drawingml/2006/main"/>
           <a:p xmlns:a="http://schemas.openxmlformats.org/drawingml/2006/main">
             <a:pPr algn="ctr">
+              <a:buNone/>
               <a:defRPr sz="2100" b="1">
                 <a:solidFill>
                   <a:srgbClr val="111111"/>
@@ -6555,6 +6609,7 @@
           <a:lstStyle xmlns:a="http://schemas.openxmlformats.org/drawingml/2006/main"/>
           <a:p xmlns:a="http://schemas.openxmlformats.org/drawingml/2006/main">
             <a:pPr algn="ctr">
+              <a:buNone/>
               <a:defRPr sz="1275" b="0">
                 <a:solidFill>
                   <a:srgbClr val="5F6368"/>
@@ -6578,6 +6633,7 @@
           </a:p>
           <a:p xmlns:a="http://schemas.openxmlformats.org/drawingml/2006/main">
             <a:pPr algn="ctr">
+              <a:buNone/>
               <a:defRPr sz="1275" b="0">
                 <a:solidFill>
                   <a:srgbClr val="5F6368"/>
@@ -6636,6 +6692,7 @@
           <a:lstStyle xmlns:a="http://schemas.openxmlformats.org/drawingml/2006/main"/>
           <a:p xmlns:a="http://schemas.openxmlformats.org/drawingml/2006/main">
             <a:pPr algn="ctr">
+              <a:buNone/>
               <a:defRPr sz="1650" b="1">
                 <a:solidFill>
                   <a:srgbClr val="E51B23"/>
@@ -6654,7 +6711,7 @@
                 <a:ea typeface="Helvetica Neue"/>
                 <a:cs typeface="Helvetica Neue"/>
               </a:rPr>
-              <a:t>Policy → recall → local inspection → visual observation → evidence retrieval → comparison → consent → cited report</a:t>
+              <a:t>Policy → recall → inspect → observe → private Lens → RAG → compare → consent → cited report</a:t>
             </a:r>
           </a:p>
         </p:txBody>
@@ -6694,6 +6751,7 @@
           <a:lstStyle xmlns:a="http://schemas.openxmlformats.org/drawingml/2006/main"/>
           <a:p xmlns:a="http://schemas.openxmlformats.org/drawingml/2006/main">
             <a:pPr algn="r">
+              <a:buNone/>
               <a:defRPr sz="1050" b="0">
                 <a:solidFill>
                   <a:srgbClr val="5F6368"/>
@@ -6752,6 +6810,7 @@
           <a:lstStyle xmlns:a="http://schemas.openxmlformats.org/drawingml/2006/main"/>
           <a:p xmlns:a="http://schemas.openxmlformats.org/drawingml/2006/main">
             <a:pPr algn="l">
+              <a:buNone/>
               <a:defRPr sz="975" b="0">
                 <a:solidFill>
                   <a:srgbClr val="5F6368"/>
@@ -6870,6 +6929,7 @@
           <a:lstStyle xmlns:a="http://schemas.openxmlformats.org/drawingml/2006/main"/>
           <a:p xmlns:a="http://schemas.openxmlformats.org/drawingml/2006/main">
             <a:pPr algn="l">
+              <a:buNone/>
               <a:defRPr sz="2925" b="1">
                 <a:solidFill>
                   <a:srgbClr val="111111"/>
@@ -6928,6 +6988,7 @@
           <a:lstStyle xmlns:a="http://schemas.openxmlformats.org/drawingml/2006/main"/>
           <a:p xmlns:a="http://schemas.openxmlformats.org/drawingml/2006/main">
             <a:pPr algn="l">
+              <a:buNone/>
               <a:defRPr sz="1575" b="0">
                 <a:solidFill>
                   <a:srgbClr val="5F6368"/>
@@ -7021,6 +7082,7 @@
           <a:lstStyle xmlns:a="http://schemas.openxmlformats.org/drawingml/2006/main"/>
           <a:p xmlns:a="http://schemas.openxmlformats.org/drawingml/2006/main">
             <a:pPr algn="l">
+              <a:buNone/>
               <a:defRPr sz="1500" b="1">
                 <a:solidFill>
                   <a:srgbClr val="5F6368"/>
@@ -7079,6 +7141,7 @@
           <a:lstStyle xmlns:a="http://schemas.openxmlformats.org/drawingml/2006/main"/>
           <a:p xmlns:a="http://schemas.openxmlformats.org/drawingml/2006/main">
             <a:pPr algn="l">
+              <a:buNone/>
               <a:defRPr sz="1875" b="1">
                 <a:solidFill>
                   <a:srgbClr val="111111"/>
@@ -7102,6 +7165,7 @@
           </a:p>
           <a:p xmlns:a="http://schemas.openxmlformats.org/drawingml/2006/main">
             <a:pPr algn="l">
+              <a:buNone/>
               <a:defRPr sz="1875" b="1">
                 <a:solidFill>
                   <a:srgbClr val="111111"/>
@@ -7125,6 +7189,7 @@
           </a:p>
           <a:p xmlns:a="http://schemas.openxmlformats.org/drawingml/2006/main">
             <a:pPr algn="l">
+              <a:buNone/>
               <a:defRPr sz="1875" b="1">
                 <a:solidFill>
                   <a:srgbClr val="111111"/>
@@ -7218,6 +7283,7 @@
           <a:lstStyle xmlns:a="http://schemas.openxmlformats.org/drawingml/2006/main"/>
           <a:p xmlns:a="http://schemas.openxmlformats.org/drawingml/2006/main">
             <a:pPr algn="l">
+              <a:buNone/>
               <a:defRPr sz="1500" b="1">
                 <a:solidFill>
                   <a:srgbClr val="E51B23"/>
@@ -7276,6 +7342,7 @@
           <a:lstStyle xmlns:a="http://schemas.openxmlformats.org/drawingml/2006/main"/>
           <a:p xmlns:a="http://schemas.openxmlformats.org/drawingml/2006/main">
             <a:pPr algn="l">
+              <a:buNone/>
               <a:defRPr sz="1725" b="1">
                 <a:solidFill>
                   <a:srgbClr val="111111"/>
@@ -7334,6 +7401,7 @@
           <a:lstStyle xmlns:a="http://schemas.openxmlformats.org/drawingml/2006/main"/>
           <a:p xmlns:a="http://schemas.openxmlformats.org/drawingml/2006/main">
             <a:pPr algn="l">
+              <a:buNone/>
               <a:defRPr sz="1575" b="0">
                 <a:solidFill>
                   <a:srgbClr val="111111"/>
@@ -7357,6 +7425,7 @@
           </a:p>
           <a:p xmlns:a="http://schemas.openxmlformats.org/drawingml/2006/main">
             <a:pPr algn="l">
+              <a:buNone/>
               <a:defRPr sz="1575" b="0">
                 <a:solidFill>
                   <a:srgbClr val="111111"/>
@@ -7380,6 +7449,7 @@
           </a:p>
           <a:p xmlns:a="http://schemas.openxmlformats.org/drawingml/2006/main">
             <a:pPr algn="l">
+              <a:buNone/>
               <a:defRPr sz="1575" b="0">
                 <a:solidFill>
                   <a:srgbClr val="111111"/>
@@ -7398,11 +7468,12 @@
                 <a:ea typeface="Helvetica Neue"/>
                 <a:cs typeface="Helvetica Neue"/>
               </a:rPr>
-              <a:t>Milvus Lite + SQLite + controlled uploads</a:t>
+              <a:t>Milvus Lite + opt-in private 108-technique Lens</a:t>
             </a:r>
           </a:p>
           <a:p xmlns:a="http://schemas.openxmlformats.org/drawingml/2006/main">
             <a:pPr algn="l">
+              <a:buNone/>
               <a:defRPr sz="1575" b="0">
                 <a:solidFill>
                   <a:srgbClr val="111111"/>
@@ -7421,7 +7492,7 @@
                 <a:ea typeface="Helvetica Neue"/>
                 <a:cs typeface="Helvetica Neue"/>
               </a:rPr>
-              <a:t>Permanent application key never enters JavaScript</a:t>
+              <a:t>SQLite + controlled uploads; permanent key stays server-side</a:t>
             </a:r>
           </a:p>
         </p:txBody>
@@ -7461,6 +7532,7 @@
           <a:lstStyle xmlns:a="http://schemas.openxmlformats.org/drawingml/2006/main"/>
           <a:p xmlns:a="http://schemas.openxmlformats.org/drawingml/2006/main">
             <a:pPr algn="ctr">
+              <a:buNone/>
               <a:defRPr sz="1575" b="1">
                 <a:solidFill>
                   <a:srgbClr val="E51B23"/>
@@ -7519,6 +7591,7 @@
           <a:lstStyle xmlns:a="http://schemas.openxmlformats.org/drawingml/2006/main"/>
           <a:p xmlns:a="http://schemas.openxmlformats.org/drawingml/2006/main">
             <a:pPr algn="r">
+              <a:buNone/>
               <a:defRPr sz="1050" b="0">
                 <a:solidFill>
                   <a:srgbClr val="5F6368"/>
@@ -7577,6 +7650,7 @@
           <a:lstStyle xmlns:a="http://schemas.openxmlformats.org/drawingml/2006/main"/>
           <a:p xmlns:a="http://schemas.openxmlformats.org/drawingml/2006/main">
             <a:pPr algn="l">
+              <a:buNone/>
               <a:defRPr sz="975" b="0">
                 <a:solidFill>
                   <a:srgbClr val="5F6368"/>
@@ -7695,6 +7769,7 @@
           <a:lstStyle xmlns:a="http://schemas.openxmlformats.org/drawingml/2006/main"/>
           <a:p xmlns:a="http://schemas.openxmlformats.org/drawingml/2006/main">
             <a:pPr algn="l">
+              <a:buNone/>
               <a:defRPr sz="2925" b="1">
                 <a:solidFill>
                   <a:srgbClr val="111111"/>
@@ -7753,6 +7828,7 @@
           <a:lstStyle xmlns:a="http://schemas.openxmlformats.org/drawingml/2006/main"/>
           <a:p xmlns:a="http://schemas.openxmlformats.org/drawingml/2006/main">
             <a:pPr algn="l">
+              <a:buNone/>
               <a:defRPr sz="2175" b="1">
                 <a:solidFill>
                   <a:srgbClr val="111111"/>
@@ -7811,6 +7887,7 @@
           <a:lstStyle xmlns:a="http://schemas.openxmlformats.org/drawingml/2006/main"/>
           <a:p xmlns:a="http://schemas.openxmlformats.org/drawingml/2006/main">
             <a:pPr algn="l">
+              <a:buNone/>
               <a:defRPr sz="1500" b="0">
                 <a:solidFill>
                   <a:srgbClr val="5F6368"/>
@@ -7869,6 +7946,7 @@
           <a:lstStyle xmlns:a="http://schemas.openxmlformats.org/drawingml/2006/main"/>
           <a:p xmlns:a="http://schemas.openxmlformats.org/drawingml/2006/main">
             <a:pPr algn="l">
+              <a:buNone/>
               <a:defRPr sz="1425" b="1">
                 <a:solidFill>
                   <a:srgbClr val="E51B23"/>
@@ -7892,6 +7970,7 @@
           </a:p>
           <a:p xmlns:a="http://schemas.openxmlformats.org/drawingml/2006/main">
             <a:pPr algn="l">
+              <a:buNone/>
               <a:defRPr sz="1425" b="1">
                 <a:solidFill>
                   <a:srgbClr val="E51B23"/>
@@ -7950,6 +8029,7 @@
           <a:lstStyle xmlns:a="http://schemas.openxmlformats.org/drawingml/2006/main"/>
           <a:p xmlns:a="http://schemas.openxmlformats.org/drawingml/2006/main">
             <a:pPr algn="l">
+              <a:buNone/>
               <a:defRPr sz="1275" b="1">
                 <a:solidFill>
                   <a:srgbClr val="E51B23"/>
@@ -8008,6 +8088,7 @@
           <a:lstStyle xmlns:a="http://schemas.openxmlformats.org/drawingml/2006/main"/>
           <a:p xmlns:a="http://schemas.openxmlformats.org/drawingml/2006/main">
             <a:pPr algn="l">
+              <a:buNone/>
               <a:defRPr sz="1500" b="1">
                 <a:solidFill>
                   <a:srgbClr val="111111"/>
@@ -8033,7 +8114,7 @@
       </p:sp>
       <p:cxnSp>
         <p:nvCxnSpPr>
-          <p:cNvPr id="28" name="opt-rule-0"/>
+          <p:cNvPr id="56" name="opt-rule-0"/>
           <p:cNvCxnSpPr/>
           <p:nvPr/>
         </p:nvCxnSpPr>
@@ -8088,6 +8169,7 @@
           <a:lstStyle xmlns:a="http://schemas.openxmlformats.org/drawingml/2006/main"/>
           <a:p xmlns:a="http://schemas.openxmlformats.org/drawingml/2006/main">
             <a:pPr algn="l">
+              <a:buNone/>
               <a:defRPr sz="1275" b="1">
                 <a:solidFill>
                   <a:srgbClr val="E51B23"/>
@@ -8146,6 +8228,7 @@
           <a:lstStyle xmlns:a="http://schemas.openxmlformats.org/drawingml/2006/main"/>
           <a:p xmlns:a="http://schemas.openxmlformats.org/drawingml/2006/main">
             <a:pPr algn="l">
+              <a:buNone/>
               <a:defRPr sz="1500" b="1">
                 <a:solidFill>
                   <a:srgbClr val="111111"/>
@@ -8171,7 +8254,7 @@
       </p:sp>
       <p:cxnSp>
         <p:nvCxnSpPr>
-          <p:cNvPr id="31" name="opt-rule-1"/>
+          <p:cNvPr id="59" name="opt-rule-1"/>
           <p:cNvCxnSpPr/>
           <p:nvPr/>
         </p:nvCxnSpPr>
@@ -8226,6 +8309,7 @@
           <a:lstStyle xmlns:a="http://schemas.openxmlformats.org/drawingml/2006/main"/>
           <a:p xmlns:a="http://schemas.openxmlformats.org/drawingml/2006/main">
             <a:pPr algn="l">
+              <a:buNone/>
               <a:defRPr sz="1275" b="1">
                 <a:solidFill>
                   <a:srgbClr val="E51B23"/>
@@ -8284,6 +8368,7 @@
           <a:lstStyle xmlns:a="http://schemas.openxmlformats.org/drawingml/2006/main"/>
           <a:p xmlns:a="http://schemas.openxmlformats.org/drawingml/2006/main">
             <a:pPr algn="l">
+              <a:buNone/>
               <a:defRPr sz="1500" b="1">
                 <a:solidFill>
                   <a:srgbClr val="111111"/>
@@ -8309,7 +8394,7 @@
       </p:sp>
       <p:cxnSp>
         <p:nvCxnSpPr>
-          <p:cNvPr id="34" name="opt-rule-2"/>
+          <p:cNvPr id="62" name="opt-rule-2"/>
           <p:cNvCxnSpPr/>
           <p:nvPr/>
         </p:nvCxnSpPr>
@@ -8364,6 +8449,7 @@
           <a:lstStyle xmlns:a="http://schemas.openxmlformats.org/drawingml/2006/main"/>
           <a:p xmlns:a="http://schemas.openxmlformats.org/drawingml/2006/main">
             <a:pPr algn="l">
+              <a:buNone/>
               <a:defRPr sz="1275" b="1">
                 <a:solidFill>
                   <a:srgbClr val="E51B23"/>
@@ -8422,6 +8508,7 @@
           <a:lstStyle xmlns:a="http://schemas.openxmlformats.org/drawingml/2006/main"/>
           <a:p xmlns:a="http://schemas.openxmlformats.org/drawingml/2006/main">
             <a:pPr algn="l">
+              <a:buNone/>
               <a:defRPr sz="1500" b="1">
                 <a:solidFill>
                   <a:srgbClr val="111111"/>
@@ -8480,6 +8567,7 @@
           <a:lstStyle xmlns:a="http://schemas.openxmlformats.org/drawingml/2006/main"/>
           <a:p xmlns:a="http://schemas.openxmlformats.org/drawingml/2006/main">
             <a:pPr algn="l">
+              <a:buNone/>
               <a:defRPr sz="1050" b="1">
                 <a:solidFill>
                   <a:srgbClr val="5F6368"/>
@@ -8538,6 +8626,7 @@
           <a:lstStyle xmlns:a="http://schemas.openxmlformats.org/drawingml/2006/main"/>
           <a:p xmlns:a="http://schemas.openxmlformats.org/drawingml/2006/main">
             <a:pPr algn="r">
+              <a:buNone/>
               <a:defRPr sz="1125" b="0">
                 <a:solidFill>
                   <a:srgbClr val="5F6368"/>
@@ -8596,6 +8685,7 @@
           <a:lstStyle xmlns:a="http://schemas.openxmlformats.org/drawingml/2006/main"/>
           <a:p xmlns:a="http://schemas.openxmlformats.org/drawingml/2006/main">
             <a:pPr algn="r">
+              <a:buNone/>
               <a:defRPr sz="1050" b="0">
                 <a:solidFill>
                   <a:srgbClr val="5F6368"/>
@@ -8654,6 +8744,7 @@
           <a:lstStyle xmlns:a="http://schemas.openxmlformats.org/drawingml/2006/main"/>
           <a:p xmlns:a="http://schemas.openxmlformats.org/drawingml/2006/main">
             <a:pPr algn="l">
+              <a:buNone/>
               <a:defRPr sz="975" b="0">
                 <a:solidFill>
                   <a:srgbClr val="5F6368"/>
@@ -8772,6 +8863,7 @@
           <a:lstStyle xmlns:a="http://schemas.openxmlformats.org/drawingml/2006/main"/>
           <a:p xmlns:a="http://schemas.openxmlformats.org/drawingml/2006/main">
             <a:pPr algn="l">
+              <a:buNone/>
               <a:defRPr sz="2925" b="1">
                 <a:solidFill>
                   <a:srgbClr val="111111"/>
@@ -8830,6 +8922,7 @@
           <a:lstStyle xmlns:a="http://schemas.openxmlformats.org/drawingml/2006/main"/>
           <a:p xmlns:a="http://schemas.openxmlformats.org/drawingml/2006/main">
             <a:pPr algn="l">
+              <a:buNone/>
               <a:defRPr sz="2175" b="1">
                 <a:solidFill>
                   <a:srgbClr val="111111"/>
@@ -8888,6 +8981,7 @@
           <a:lstStyle xmlns:a="http://schemas.openxmlformats.org/drawingml/2006/main"/>
           <a:p xmlns:a="http://schemas.openxmlformats.org/drawingml/2006/main">
             <a:pPr algn="l">
+              <a:buNone/>
               <a:defRPr sz="1425" b="0">
                 <a:solidFill>
                   <a:srgbClr val="5F6368"/>
@@ -8911,6 +9005,7 @@
           </a:p>
           <a:p xmlns:a="http://schemas.openxmlformats.org/drawingml/2006/main">
             <a:pPr algn="l">
+              <a:buNone/>
               <a:defRPr sz="1425" b="0">
                 <a:solidFill>
                   <a:srgbClr val="5F6368"/>
@@ -8929,7 +9024,7 @@
                 <a:ea typeface="Helvetica Neue"/>
                 <a:cs typeface="Helvetica Neue"/>
               </a:rPr>
-              <a:t>Blocks identity, personality, employability, health, wealth, protected-attribute, and destiny inference.</a:t>
+              <a:t>Blocks identity, personality, health, wealth, protected-attribute, and predictive inference.</a:t>
             </a:r>
           </a:p>
           <a:p xmlns:a="http://schemas.openxmlformats.org/drawingml/2006/main">
@@ -8939,6 +9034,7 @@
           </a:p>
           <a:p xmlns:a="http://schemas.openxmlformats.org/drawingml/2006/main">
             <a:pPr algn="l">
+              <a:buNone/>
               <a:defRPr sz="1425" b="0">
                 <a:solidFill>
                   <a:srgbClr val="5F6368"/>
@@ -8957,11 +9053,12 @@
                 <a:ea typeface="Helvetica Neue"/>
                 <a:cs typeface="Helvetica Neue"/>
               </a:rPr>
-              <a:t>Cited context</a:t>
+              <a:t>Public + private context</a:t>
             </a:r>
           </a:p>
           <a:p xmlns:a="http://schemas.openxmlformats.org/drawingml/2006/main">
             <a:pPr algn="l">
+              <a:buNone/>
               <a:defRPr sz="1425" b="0">
                 <a:solidFill>
                   <a:srgbClr val="5F6368"/>
@@ -8980,7 +9077,7 @@
                 <a:ea typeface="Helvetica Neue"/>
                 <a:cs typeface="Helvetica Neue"/>
               </a:rPr>
-              <a:t>Cultural associations remain bounded, source-backed, and explicitly ambiguous.</a:t>
+              <a:t>Public claims stay cited; private course associations are opt-in, runtime-only, and safety-filtered.</a:t>
             </a:r>
           </a:p>
           <a:p xmlns:a="http://schemas.openxmlformats.org/drawingml/2006/main">
@@ -8990,6 +9087,7 @@
           </a:p>
           <a:p xmlns:a="http://schemas.openxmlformats.org/drawingml/2006/main">
             <a:pPr algn="l">
+              <a:buNone/>
               <a:defRPr sz="1425" b="0">
                 <a:solidFill>
                   <a:srgbClr val="5F6368"/>
@@ -9013,6 +9111,7 @@
           </a:p>
           <a:p xmlns:a="http://schemas.openxmlformats.org/drawingml/2006/main">
             <a:pPr algn="l">
+              <a:buNone/>
               <a:defRPr sz="1425" b="0">
                 <a:solidFill>
                   <a:srgbClr val="5F6368"/>
@@ -9073,14 +9172,14 @@
       </p:sp>
       <p:pic>
         <p:nvPicPr>
-          <p:cNvPr id="15" name=""/>
+          <p:cNvPr id="17" name=""/>
           <p:cNvPicPr>
             <a:picLocks xmlns:a="http://schemas.openxmlformats.org/drawingml/2006/main" noChangeAspect="1"/>
           </p:cNvPicPr>
           <p:nvPr/>
         </p:nvPicPr>
         <p:blipFill>
-          <a:blip xmlns:r="http://schemas.openxmlformats.org/officeDocument/2006/relationships" xmlns:a="http://schemas.openxmlformats.org/drawingml/2006/main" r:embed="Reb9d9b10978748cd"/>
+          <a:blip xmlns:r="http://schemas.openxmlformats.org/officeDocument/2006/relationships" xmlns:a="http://schemas.openxmlformats.org/drawingml/2006/main" r:embed="Rc6220d25126d4c49"/>
           <a:srcRect xmlns:a="http://schemas.openxmlformats.org/drawingml/2006/main" l="0" t="17748" r="0" b="17748"/>
           <a:stretch xmlns:a="http://schemas.openxmlformats.org/drawingml/2006/main">
             <a:fillRect l="0" t="0" r="0" b="0"/>
@@ -9133,6 +9232,7 @@
           <a:lstStyle xmlns:a="http://schemas.openxmlformats.org/drawingml/2006/main"/>
           <a:p xmlns:a="http://schemas.openxmlformats.org/drawingml/2006/main">
             <a:pPr algn="ctr">
+              <a:buNone/>
               <a:defRPr sz="1200" b="1">
                 <a:solidFill>
                   <a:srgbClr val="111111"/>
@@ -9156,6 +9256,7 @@
           </a:p>
           <a:p xmlns:a="http://schemas.openxmlformats.org/drawingml/2006/main">
             <a:pPr algn="ctr">
+              <a:buNone/>
               <a:defRPr sz="1200" b="1">
                 <a:solidFill>
                   <a:srgbClr val="111111"/>
@@ -9214,6 +9315,7 @@
           <a:lstStyle xmlns:a="http://schemas.openxmlformats.org/drawingml/2006/main"/>
           <a:p xmlns:a="http://schemas.openxmlformats.org/drawingml/2006/main">
             <a:pPr algn="r">
+              <a:buNone/>
               <a:defRPr sz="1050" b="0">
                 <a:solidFill>
                   <a:srgbClr val="5F6368"/>
@@ -9272,6 +9374,7 @@
           <a:lstStyle xmlns:a="http://schemas.openxmlformats.org/drawingml/2006/main"/>
           <a:p xmlns:a="http://schemas.openxmlformats.org/drawingml/2006/main">
             <a:pPr algn="l">
+              <a:buNone/>
               <a:defRPr sz="975" b="0">
                 <a:solidFill>
                   <a:srgbClr val="5F6368"/>
@@ -9390,6 +9493,7 @@
           <a:lstStyle xmlns:a="http://schemas.openxmlformats.org/drawingml/2006/main"/>
           <a:p xmlns:a="http://schemas.openxmlformats.org/drawingml/2006/main">
             <a:pPr algn="l">
+              <a:buNone/>
               <a:defRPr sz="1575" b="1">
                 <a:solidFill>
                   <a:srgbClr val="E51B23"/>
@@ -9448,6 +9552,7 @@
           <a:lstStyle xmlns:a="http://schemas.openxmlformats.org/drawingml/2006/main"/>
           <a:p xmlns:a="http://schemas.openxmlformats.org/drawingml/2006/main">
             <a:pPr algn="l">
+              <a:buNone/>
               <a:defRPr sz="5700" b="1">
                 <a:solidFill>
                   <a:srgbClr val="111111"/>
@@ -9471,6 +9576,7 @@
           </a:p>
           <a:p xmlns:a="http://schemas.openxmlformats.org/drawingml/2006/main">
             <a:pPr algn="l">
+              <a:buNone/>
               <a:defRPr sz="5700" b="1">
                 <a:solidFill>
                   <a:srgbClr val="111111"/>
@@ -9529,6 +9635,7 @@
           <a:lstStyle xmlns:a="http://schemas.openxmlformats.org/drawingml/2006/main"/>
           <a:p xmlns:a="http://schemas.openxmlformats.org/drawingml/2006/main">
             <a:pPr algn="l">
+              <a:buNone/>
               <a:defRPr sz="1875" b="1">
                 <a:solidFill>
                   <a:srgbClr val="111111"/>
@@ -9552,6 +9659,7 @@
           </a:p>
           <a:p xmlns:a="http://schemas.openxmlformats.org/drawingml/2006/main">
             <a:pPr algn="l">
+              <a:buNone/>
               <a:defRPr sz="1875" b="1">
                 <a:solidFill>
                   <a:srgbClr val="111111"/>
@@ -9570,11 +9678,12 @@
                 <a:ea typeface="Helvetica Neue"/>
                 <a:cs typeface="Helvetica Neue"/>
               </a:rPr>
-              <a:t>32 inspectable knowledge cards</a:t>
+              <a:t>32 inspectable public knowledge cards</a:t>
             </a:r>
           </a:p>
           <a:p xmlns:a="http://schemas.openxmlformats.org/drawingml/2006/main">
             <a:pPr algn="l">
+              <a:buNone/>
               <a:defRPr sz="1875" b="1">
                 <a:solidFill>
                   <a:srgbClr val="111111"/>
@@ -9593,11 +9702,12 @@
                 <a:ea typeface="Helvetica Neue"/>
                 <a:cs typeface="Helvetica Neue"/>
               </a:rPr>
-              <a:t>8 retrieval smoke queries</a:t>
+              <a:t>1 opt-in private Lens Tool</a:t>
             </a:r>
           </a:p>
           <a:p xmlns:a="http://schemas.openxmlformats.org/drawingml/2006/main">
             <a:pPr algn="l">
+              <a:buNone/>
               <a:defRPr sz="1875" b="1">
                 <a:solidFill>
                   <a:srgbClr val="111111"/>
@@ -9656,6 +9766,7 @@
           <a:lstStyle xmlns:a="http://schemas.openxmlformats.org/drawingml/2006/main"/>
           <a:p xmlns:a="http://schemas.openxmlformats.org/drawingml/2006/main">
             <a:pPr algn="l">
+              <a:buNone/>
               <a:defRPr sz="1800" b="1">
                 <a:solidFill>
                   <a:srgbClr val="5F6368"/>
@@ -9674,7 +9785,7 @@
                 <a:ea typeface="Helvetica Neue"/>
                 <a:cs typeface="Helvetica Neue"/>
               </a:rPr>
-              <a:t>Upload → inspect → observe → retrieve → compare → consent → report</a:t>
+              <a:t>Upload → inspect → observe → private Lens → retrieve → compare → consent → report</a:t>
             </a:r>
           </a:p>
         </p:txBody>
@@ -9714,6 +9825,7 @@
           <a:lstStyle xmlns:a="http://schemas.openxmlformats.org/drawingml/2006/main"/>
           <a:p xmlns:a="http://schemas.openxmlformats.org/drawingml/2006/main">
             <a:pPr algn="l">
+              <a:buNone/>
               <a:defRPr sz="1500" b="1">
                 <a:solidFill>
                   <a:srgbClr val="E51B23"/>
@@ -9737,6 +9849,7 @@
           </a:p>
           <a:p xmlns:a="http://schemas.openxmlformats.org/drawingml/2006/main">
             <a:pPr algn="l">
+              <a:buNone/>
               <a:defRPr sz="1500" b="1">
                 <a:solidFill>
                   <a:srgbClr val="E51B23"/>
@@ -9795,6 +9908,7 @@
           <a:lstStyle xmlns:a="http://schemas.openxmlformats.org/drawingml/2006/main"/>
           <a:p xmlns:a="http://schemas.openxmlformats.org/drawingml/2006/main">
             <a:pPr algn="r">
+              <a:buNone/>
               <a:defRPr sz="1125" b="1">
                 <a:solidFill>
                   <a:srgbClr val="5F6368"/>

</xml_diff>